<commit_message>
Ch4 cerrado, borrador ch5, arquitectura actualizada
</commit_message>
<xml_diff>
--- a/ARQUITECTURAS.pptx
+++ b/ARQUITECTURAS.pptx
@@ -199,7 +199,7 @@
           <a:p>
             <a:fld id="{648875B9-81E3-48EB-AC45-E2B16239D10D}" type="datetimeFigureOut">
               <a:rPr lang="es-ES" smtClean="0"/>
-              <a:t>05/05/2026</a:t>
+              <a:t>06/05/2026</a:t>
             </a:fld>
             <a:endParaRPr lang="es-ES"/>
           </a:p>
@@ -805,7 +805,7 @@
           <a:p>
             <a:fld id="{31F888AD-2037-4E90-B50F-EBB1A322544F}" type="datetimeFigureOut">
               <a:rPr lang="es-ES" smtClean="0"/>
-              <a:t>05/05/2026</a:t>
+              <a:t>06/05/2026</a:t>
             </a:fld>
             <a:endParaRPr lang="es-ES"/>
           </a:p>
@@ -1003,7 +1003,7 @@
           <a:p>
             <a:fld id="{31F888AD-2037-4E90-B50F-EBB1A322544F}" type="datetimeFigureOut">
               <a:rPr lang="es-ES" smtClean="0"/>
-              <a:t>05/05/2026</a:t>
+              <a:t>06/05/2026</a:t>
             </a:fld>
             <a:endParaRPr lang="es-ES"/>
           </a:p>
@@ -1211,7 +1211,7 @@
           <a:p>
             <a:fld id="{31F888AD-2037-4E90-B50F-EBB1A322544F}" type="datetimeFigureOut">
               <a:rPr lang="es-ES" smtClean="0"/>
-              <a:t>05/05/2026</a:t>
+              <a:t>06/05/2026</a:t>
             </a:fld>
             <a:endParaRPr lang="es-ES"/>
           </a:p>
@@ -1444,7 +1444,7 @@
           <a:p>
             <a:fld id="{31F888AD-2037-4E90-B50F-EBB1A322544F}" type="datetimeFigureOut">
               <a:rPr lang="es-ES" smtClean="0"/>
-              <a:t>05/05/2026</a:t>
+              <a:t>06/05/2026</a:t>
             </a:fld>
             <a:endParaRPr lang="es-ES"/>
           </a:p>
@@ -1719,7 +1719,7 @@
           <a:p>
             <a:fld id="{31F888AD-2037-4E90-B50F-EBB1A322544F}" type="datetimeFigureOut">
               <a:rPr lang="es-ES" smtClean="0"/>
-              <a:t>05/05/2026</a:t>
+              <a:t>06/05/2026</a:t>
             </a:fld>
             <a:endParaRPr lang="es-ES"/>
           </a:p>
@@ -1984,7 +1984,7 @@
           <a:p>
             <a:fld id="{31F888AD-2037-4E90-B50F-EBB1A322544F}" type="datetimeFigureOut">
               <a:rPr lang="es-ES" smtClean="0"/>
-              <a:t>05/05/2026</a:t>
+              <a:t>06/05/2026</a:t>
             </a:fld>
             <a:endParaRPr lang="es-ES"/>
           </a:p>
@@ -2396,7 +2396,7 @@
           <a:p>
             <a:fld id="{31F888AD-2037-4E90-B50F-EBB1A322544F}" type="datetimeFigureOut">
               <a:rPr lang="es-ES" smtClean="0"/>
-              <a:t>05/05/2026</a:t>
+              <a:t>06/05/2026</a:t>
             </a:fld>
             <a:endParaRPr lang="es-ES"/>
           </a:p>
@@ -2537,7 +2537,7 @@
           <a:p>
             <a:fld id="{31F888AD-2037-4E90-B50F-EBB1A322544F}" type="datetimeFigureOut">
               <a:rPr lang="es-ES" smtClean="0"/>
-              <a:t>05/05/2026</a:t>
+              <a:t>06/05/2026</a:t>
             </a:fld>
             <a:endParaRPr lang="es-ES"/>
           </a:p>
@@ -2650,7 +2650,7 @@
           <a:p>
             <a:fld id="{31F888AD-2037-4E90-B50F-EBB1A322544F}" type="datetimeFigureOut">
               <a:rPr lang="es-ES" smtClean="0"/>
-              <a:t>05/05/2026</a:t>
+              <a:t>06/05/2026</a:t>
             </a:fld>
             <a:endParaRPr lang="es-ES"/>
           </a:p>
@@ -2961,7 +2961,7 @@
           <a:p>
             <a:fld id="{31F888AD-2037-4E90-B50F-EBB1A322544F}" type="datetimeFigureOut">
               <a:rPr lang="es-ES" smtClean="0"/>
-              <a:t>05/05/2026</a:t>
+              <a:t>06/05/2026</a:t>
             </a:fld>
             <a:endParaRPr lang="es-ES"/>
           </a:p>
@@ -3249,7 +3249,7 @@
           <a:p>
             <a:fld id="{31F888AD-2037-4E90-B50F-EBB1A322544F}" type="datetimeFigureOut">
               <a:rPr lang="es-ES" smtClean="0"/>
-              <a:t>05/05/2026</a:t>
+              <a:t>06/05/2026</a:t>
             </a:fld>
             <a:endParaRPr lang="es-ES"/>
           </a:p>
@@ -3490,7 +3490,7 @@
           <a:p>
             <a:fld id="{31F888AD-2037-4E90-B50F-EBB1A322544F}" type="datetimeFigureOut">
               <a:rPr lang="es-ES" smtClean="0"/>
-              <a:t>05/05/2026</a:t>
+              <a:t>06/05/2026</a:t>
             </a:fld>
             <a:endParaRPr lang="es-ES"/>
           </a:p>
@@ -9801,8 +9801,8 @@
           </p:blipFill>
           <p:spPr>
             <a:xfrm>
-              <a:off x="6621448" y="6194520"/>
-              <a:ext cx="1461406" cy="360756"/>
+              <a:off x="7012060" y="6263770"/>
+              <a:ext cx="1135748" cy="280366"/>
             </a:xfrm>
             <a:prstGeom prst="rect">
               <a:avLst/>
@@ -9932,6 +9932,51 @@
           </a:prstGeom>
         </p:spPr>
       </p:pic>
+      <p:sp>
+        <p:nvSpPr>
+          <p:cNvPr id="8" name="Text 34">
+            <a:extLst>
+              <a:ext uri="{FF2B5EF4-FFF2-40B4-BE49-F238E27FC236}">
+                <a16:creationId xmlns:a16="http://schemas.microsoft.com/office/drawing/2014/main" id="{B15F765C-BCFE-F8CA-34E2-474EE679A89E}"/>
+              </a:ext>
+            </a:extLst>
+          </p:cNvPr>
+          <p:cNvSpPr/>
+          <p:nvPr/>
+        </p:nvSpPr>
+        <p:spPr>
+          <a:xfrm>
+            <a:off x="6361867" y="6288790"/>
+            <a:ext cx="675132" cy="169869"/>
+          </a:xfrm>
+          <a:prstGeom prst="rect">
+            <a:avLst/>
+          </a:prstGeom>
+          <a:noFill/>
+          <a:ln/>
+        </p:spPr>
+        <p:txBody>
+          <a:bodyPr wrap="square" lIns="0" tIns="0" rIns="0" bIns="0" rtlCol="0" anchor="ctr"/>
+          <a:lstStyle/>
+          <a:p>
+            <a:pPr marL="0" indent="0" algn="ctr">
+              <a:buNone/>
+            </a:pPr>
+            <a:r>
+              <a:rPr lang="en-US" sz="2000" b="1" dirty="0">
+                <a:solidFill>
+                  <a:srgbClr val="212121"/>
+                </a:solidFill>
+                <a:latin typeface="Calibri" pitchFamily="34" charset="0"/>
+                <a:ea typeface="Calibri" pitchFamily="34" charset="-122"/>
+                <a:cs typeface="Calibri" pitchFamily="34" charset="-120"/>
+              </a:rPr>
+              <a:t>DNN</a:t>
+            </a:r>
+            <a:endParaRPr lang="en-US" sz="2000" dirty="0"/>
+          </a:p>
+        </p:txBody>
+      </p:sp>
     </p:spTree>
   </p:cSld>
   <p:clrMapOvr>
@@ -18147,6 +18192,23 @@
 </file>
 
 <file path=customXml/item1.xml><?xml version="1.0" encoding="utf-8"?>
+<p:properties xmlns:p="http://schemas.microsoft.com/office/2006/metadata/properties" xmlns:xsi="http://www.w3.org/2001/XMLSchema-instance" xmlns:pc="http://schemas.microsoft.com/office/infopath/2007/PartnerControls">
+  <documentManagement>
+    <_activity xmlns="da169425-153d-4080-8705-45c92938e7f0" xsi:nil="true"/>
+  </documentManagement>
+</p:properties>
+</file>
+
+<file path=customXml/item2.xml><?xml version="1.0" encoding="utf-8"?>
+<?mso-contentType ?>
+<FormTemplates xmlns="http://schemas.microsoft.com/sharepoint/v3/contenttype/forms">
+  <Display>DocumentLibraryForm</Display>
+  <Edit>DocumentLibraryForm</Edit>
+  <New>DocumentLibraryForm</New>
+</FormTemplates>
+</file>
+
+<file path=customXml/item3.xml><?xml version="1.0" encoding="utf-8"?>
 <ct:contentTypeSchema xmlns:ct="http://schemas.microsoft.com/office/2006/metadata/contentType" xmlns:ma="http://schemas.microsoft.com/office/2006/metadata/properties/metaAttributes" ct:_="" ma:_="" ma:contentTypeName="Documento" ma:contentTypeID="0x010100DEA5B49C5DE5F44CB629258CFB70E19D" ma:contentTypeVersion="18" ma:contentTypeDescription="Crear nuevo documento." ma:contentTypeScope="" ma:versionID="74d7687ff137e87fb3b1bb4914d165da">
   <xsd:schema xmlns:xsd="http://www.w3.org/2001/XMLSchema" xmlns:xs="http://www.w3.org/2001/XMLSchema" xmlns:p="http://schemas.microsoft.com/office/2006/metadata/properties" xmlns:ns3="da169425-153d-4080-8705-45c92938e7f0" xmlns:ns4="89f1de4a-40f7-4e81-987b-401414521485" targetNamespace="http://schemas.microsoft.com/office/2006/metadata/properties" ma:root="true" ma:fieldsID="4c882593e756bab23045d9ebaf71ae2a" ns3:_="" ns4:_="">
     <xsd:import namespace="da169425-153d-4080-8705-45c92938e7f0"/>
@@ -18399,24 +18461,32 @@
 </ct:contentTypeSchema>
 </file>
 
-<file path=customXml/item2.xml><?xml version="1.0" encoding="utf-8"?>
-<?mso-contentType ?>
-<FormTemplates xmlns="http://schemas.microsoft.com/sharepoint/v3/contenttype/forms">
-  <Display>DocumentLibraryForm</Display>
-  <Edit>DocumentLibraryForm</Edit>
-  <New>DocumentLibraryForm</New>
-</FormTemplates>
+<file path=customXml/itemProps1.xml><?xml version="1.0" encoding="utf-8"?>
+<ds:datastoreItem xmlns:ds="http://schemas.openxmlformats.org/officeDocument/2006/customXml" ds:itemID="{E10D70F7-8416-46C5-896C-E4C67671FD25}">
+  <ds:schemaRefs>
+    <ds:schemaRef ds:uri="89f1de4a-40f7-4e81-987b-401414521485"/>
+    <ds:schemaRef ds:uri="http://purl.org/dc/dcmitype/"/>
+    <ds:schemaRef ds:uri="http://www.w3.org/XML/1998/namespace"/>
+    <ds:schemaRef ds:uri="http://purl.org/dc/terms/"/>
+    <ds:schemaRef ds:uri="http://schemas.microsoft.com/office/2006/metadata/properties"/>
+    <ds:schemaRef ds:uri="http://purl.org/dc/elements/1.1/"/>
+    <ds:schemaRef ds:uri="http://schemas.microsoft.com/office/2006/documentManagement/types"/>
+    <ds:schemaRef ds:uri="http://schemas.microsoft.com/office/infopath/2007/PartnerControls"/>
+    <ds:schemaRef ds:uri="http://schemas.openxmlformats.org/package/2006/metadata/core-properties"/>
+    <ds:schemaRef ds:uri="da169425-153d-4080-8705-45c92938e7f0"/>
+  </ds:schemaRefs>
+</ds:datastoreItem>
 </file>
 
-<file path=customXml/item3.xml><?xml version="1.0" encoding="utf-8"?>
-<p:properties xmlns:p="http://schemas.microsoft.com/office/2006/metadata/properties" xmlns:xsi="http://www.w3.org/2001/XMLSchema-instance" xmlns:pc="http://schemas.microsoft.com/office/infopath/2007/PartnerControls">
-  <documentManagement>
-    <_activity xmlns="da169425-153d-4080-8705-45c92938e7f0" xsi:nil="true"/>
-  </documentManagement>
-</p:properties>
+<file path=customXml/itemProps2.xml><?xml version="1.0" encoding="utf-8"?>
+<ds:datastoreItem xmlns:ds="http://schemas.openxmlformats.org/officeDocument/2006/customXml" ds:itemID="{4E1C400D-5C3C-43E3-9C88-F800C5BA2249}">
+  <ds:schemaRefs>
+    <ds:schemaRef ds:uri="http://schemas.microsoft.com/sharepoint/v3/contenttype/forms"/>
+  </ds:schemaRefs>
+</ds:datastoreItem>
 </file>
 
-<file path=customXml/itemProps1.xml><?xml version="1.0" encoding="utf-8"?>
+<file path=customXml/itemProps3.xml><?xml version="1.0" encoding="utf-8"?>
 <ds:datastoreItem xmlns:ds="http://schemas.openxmlformats.org/officeDocument/2006/customXml" ds:itemID="{F22018BE-1405-4A4B-BB67-C88962BABDE1}">
   <ds:schemaRefs>
     <ds:schemaRef ds:uri="http://schemas.microsoft.com/office/2006/metadata/contentType"/>
@@ -18433,29 +18503,4 @@
     <ds:schemaRef ds:uri="http://schemas.microsoft.com/internal/obd"/>
   </ds:schemaRefs>
 </ds:datastoreItem>
-</file>
-
-<file path=customXml/itemProps2.xml><?xml version="1.0" encoding="utf-8"?>
-<ds:datastoreItem xmlns:ds="http://schemas.openxmlformats.org/officeDocument/2006/customXml" ds:itemID="{4E1C400D-5C3C-43E3-9C88-F800C5BA2249}">
-  <ds:schemaRefs>
-    <ds:schemaRef ds:uri="http://schemas.microsoft.com/sharepoint/v3/contenttype/forms"/>
-  </ds:schemaRefs>
-</ds:datastoreItem>
-</file>
-
-<file path=customXml/itemProps3.xml><?xml version="1.0" encoding="utf-8"?>
-<ds:datastoreItem xmlns:ds="http://schemas.openxmlformats.org/officeDocument/2006/customXml" ds:itemID="{E10D70F7-8416-46C5-896C-E4C67671FD25}">
-  <ds:schemaRefs>
-    <ds:schemaRef ds:uri="http://schemas.microsoft.com/office/2006/metadata/properties"/>
-    <ds:schemaRef ds:uri="da169425-153d-4080-8705-45c92938e7f0"/>
-    <ds:schemaRef ds:uri="http://purl.org/dc/elements/1.1/"/>
-    <ds:schemaRef ds:uri="http://schemas.microsoft.com/office/2006/documentManagement/types"/>
-    <ds:schemaRef ds:uri="http://schemas.openxmlformats.org/package/2006/metadata/core-properties"/>
-    <ds:schemaRef ds:uri="http://purl.org/dc/dcmitype/"/>
-    <ds:schemaRef ds:uri="http://schemas.microsoft.com/office/infopath/2007/PartnerControls"/>
-    <ds:schemaRef ds:uri="89f1de4a-40f7-4e81-987b-401414521485"/>
-    <ds:schemaRef ds:uri="http://www.w3.org/XML/1998/namespace"/>
-    <ds:schemaRef ds:uri="http://purl.org/dc/terms/"/>
-  </ds:schemaRefs>
-</ds:datastoreItem>
 </file>
</xml_diff>

<commit_message>
remate ch4 y empezamos ch5
</commit_message>
<xml_diff>
--- a/ARQUITECTURAS.pptx
+++ b/ARQUITECTURAS.pptx
@@ -10022,8 +10022,8 @@
         </p:nvSpPr>
         <p:spPr>
           <a:xfrm>
-            <a:off x="9913676" y="3740415"/>
-            <a:ext cx="2210348" cy="2970482"/>
+            <a:off x="9876493" y="4103645"/>
+            <a:ext cx="2210348" cy="2244395"/>
           </a:xfrm>
           <a:prstGeom prst="roundRect">
             <a:avLst>
@@ -10080,7 +10080,7 @@
         </p:nvSpPr>
         <p:spPr>
           <a:xfrm>
-            <a:off x="9913675" y="3740415"/>
+            <a:off x="9876492" y="4103645"/>
             <a:ext cx="2210348" cy="601033"/>
           </a:xfrm>
           <a:prstGeom prst="roundRect">
@@ -12566,7 +12566,7 @@
           <p:spPr>
             <a:xfrm>
               <a:off x="778873" y="825583"/>
-              <a:ext cx="694365" cy="263359"/>
+              <a:ext cx="592177" cy="263359"/>
             </a:xfrm>
             <a:prstGeom prst="rect">
               <a:avLst/>
@@ -12578,7 +12578,7 @@
             <a:bodyPr wrap="square" lIns="0" tIns="0" rIns="0" bIns="0" rtlCol="0" anchor="ctr"/>
             <a:lstStyle/>
             <a:p>
-              <a:pPr marL="0" indent="0">
+              <a:pPr marL="0" indent="0" algn="ctr">
                 <a:buNone/>
               </a:pPr>
               <a:r>
@@ -12646,8 +12646,8 @@
           </p:nvSpPr>
           <p:spPr>
             <a:xfrm>
-              <a:off x="778873" y="1372956"/>
-              <a:ext cx="1096165" cy="263359"/>
+              <a:off x="757440" y="1372956"/>
+              <a:ext cx="607596" cy="263359"/>
             </a:xfrm>
             <a:prstGeom prst="rect">
               <a:avLst/>
@@ -12659,7 +12659,7 @@
             <a:bodyPr wrap="square" lIns="0" tIns="0" rIns="0" bIns="0" rtlCol="0" anchor="ctr"/>
             <a:lstStyle/>
             <a:p>
-              <a:pPr marL="0" indent="0">
+              <a:pPr marL="0" indent="0" algn="ctr">
                 <a:buNone/>
               </a:pPr>
               <a:r>
@@ -12831,8 +12831,8 @@
           </p:nvSpPr>
           <p:spPr>
             <a:xfrm>
-              <a:off x="886752" y="2186232"/>
-              <a:ext cx="494541" cy="435921"/>
+              <a:off x="747787" y="2184665"/>
+              <a:ext cx="611337" cy="435921"/>
             </a:xfrm>
             <a:prstGeom prst="rect">
               <a:avLst/>
@@ -12844,7 +12844,7 @@
             <a:bodyPr wrap="square" lIns="0" tIns="0" rIns="0" bIns="0" rtlCol="0" anchor="ctr"/>
             <a:lstStyle/>
             <a:p>
-              <a:pPr marL="0" indent="0">
+              <a:pPr marL="0" indent="0" algn="ctr">
                 <a:buNone/>
               </a:pPr>
               <a:r>
@@ -12869,7 +12869,7 @@
                 </a:rPr>
               </a:br>
               <a:r>
-                <a:rPr lang="en-US" sz="1400" b="1" dirty="0">
+                <a:rPr lang="en-US" sz="1400" b="1" dirty="0" err="1">
                   <a:solidFill>
                     <a:srgbClr val="212121"/>
                   </a:solidFill>
@@ -12877,7 +12877,7 @@
                   <a:ea typeface="Calibri" pitchFamily="34" charset="-122"/>
                   <a:cs typeface="Calibri" pitchFamily="34" charset="-120"/>
                 </a:rPr>
-                <a:t>Social</a:t>
+                <a:t>Usuario</a:t>
               </a:r>
               <a:endParaRPr lang="en-US" dirty="0"/>
             </a:p>
@@ -14057,7 +14057,7 @@
                 <a:ea typeface="Calibri" panose="020F0502020204030204" pitchFamily="34" charset="0"/>
                 <a:cs typeface="Calibri" panose="020F0502020204030204" pitchFamily="34" charset="0"/>
               </a:rPr>
-              <a:t>Agrega</a:t>
+              <a:t>Agregación</a:t>
             </a:r>
             <a:r>
               <a:rPr lang="en-US" sz="1100" b="1" dirty="0">
@@ -14070,7 +14070,7 @@
                 <a:ea typeface="Calibri" panose="020F0502020204030204" pitchFamily="34" charset="0"/>
                 <a:cs typeface="Calibri" panose="020F0502020204030204" pitchFamily="34" charset="0"/>
               </a:rPr>
-              <a:t> variables </a:t>
+              <a:t> de variables </a:t>
             </a:r>
             <a:r>
               <a:rPr lang="en-US" sz="1100" b="1" dirty="0" err="1">
@@ -14157,7 +14157,7 @@
                 <a:ea typeface="Calibri" panose="020F0502020204030204" pitchFamily="34" charset="0"/>
                 <a:cs typeface="Calibri" panose="020F0502020204030204" pitchFamily="34" charset="0"/>
               </a:rPr>
-              <a:t>Convierte</a:t>
+              <a:t>Conversión</a:t>
             </a:r>
             <a:r>
               <a:rPr lang="en-US" sz="1100" b="1" dirty="0">
@@ -14170,7 +14170,7 @@
                 <a:ea typeface="Calibri" panose="020F0502020204030204" pitchFamily="34" charset="0"/>
                 <a:cs typeface="Calibri" panose="020F0502020204030204" pitchFamily="34" charset="0"/>
               </a:rPr>
-              <a:t> </a:t>
+              <a:t> de </a:t>
             </a:r>
             <a:r>
               <a:rPr lang="en-US" sz="1100" b="1" dirty="0" err="1">
@@ -14183,47 +14183,18 @@
                 <a:ea typeface="Calibri" panose="020F0502020204030204" pitchFamily="34" charset="0"/>
                 <a:cs typeface="Calibri" panose="020F0502020204030204" pitchFamily="34" charset="0"/>
               </a:rPr>
-              <a:t>duraciones</a:t>
+              <a:t>unidades</a:t>
             </a:r>
-            <a:r>
-              <a:rPr lang="en-US" sz="1100" b="1" dirty="0">
-                <a:solidFill>
-                  <a:schemeClr val="bg2">
-                    <a:lumMod val="50000"/>
-                  </a:schemeClr>
-                </a:solidFill>
-                <a:latin typeface="Calibri" panose="020F0502020204030204" pitchFamily="34" charset="0"/>
-                <a:ea typeface="Calibri" panose="020F0502020204030204" pitchFamily="34" charset="0"/>
-                <a:cs typeface="Calibri" panose="020F0502020204030204" pitchFamily="34" charset="0"/>
-              </a:rPr>
-              <a:t> (h) </a:t>
-            </a:r>
-            <a:r>
-              <a:rPr lang="en-US" sz="1100" b="1" dirty="0">
-                <a:solidFill>
-                  <a:schemeClr val="bg2">
-                    <a:lumMod val="50000"/>
-                  </a:schemeClr>
-                </a:solidFill>
-                <a:latin typeface="Times New Roman" panose="02020603050405020304" pitchFamily="18" charset="0"/>
-                <a:ea typeface="Calibri" panose="020F0502020204030204" pitchFamily="34" charset="0"/>
-                <a:cs typeface="Times New Roman" panose="02020603050405020304" pitchFamily="18" charset="0"/>
-              </a:rPr>
-              <a:t>→ </a:t>
-            </a:r>
-            <a:r>
-              <a:rPr lang="en-US" sz="1100" b="1" dirty="0">
-                <a:solidFill>
-                  <a:schemeClr val="bg2">
-                    <a:lumMod val="50000"/>
-                  </a:schemeClr>
-                </a:solidFill>
-                <a:latin typeface="Calibri" panose="020F0502020204030204" pitchFamily="34" charset="0"/>
-                <a:ea typeface="Calibri" panose="020F0502020204030204" pitchFamily="34" charset="0"/>
-                <a:cs typeface="Calibri" panose="020F0502020204030204" pitchFamily="34" charset="0"/>
-              </a:rPr>
-              <a:t>(s)</a:t>
-            </a:r>
+            <a:endParaRPr lang="en-US" sz="1100" b="1" dirty="0">
+              <a:solidFill>
+                <a:schemeClr val="bg2">
+                  <a:lumMod val="50000"/>
+                </a:schemeClr>
+              </a:solidFill>
+              <a:latin typeface="Calibri" panose="020F0502020204030204" pitchFamily="34" charset="0"/>
+              <a:ea typeface="Calibri" panose="020F0502020204030204" pitchFamily="34" charset="0"/>
+              <a:cs typeface="Calibri" panose="020F0502020204030204" pitchFamily="34" charset="0"/>
+            </a:endParaRPr>
           </a:p>
           <a:p>
             <a:pPr marL="171450" indent="-171450">
@@ -14340,10 +14311,10 @@
         </p:nvGrpSpPr>
         <p:grpSpPr>
           <a:xfrm>
-            <a:off x="5504834" y="3769014"/>
-            <a:ext cx="1677036" cy="2911674"/>
+            <a:off x="5504834" y="4587163"/>
+            <a:ext cx="1677036" cy="1279645"/>
             <a:chOff x="5472688" y="3569096"/>
-            <a:chExt cx="1677036" cy="2911674"/>
+            <a:chExt cx="1677036" cy="1279645"/>
           </a:xfrm>
         </p:grpSpPr>
         <p:grpSp>
@@ -14361,9 +14332,9 @@
           <p:grpSpPr>
             <a:xfrm>
               <a:off x="5477218" y="3569096"/>
-              <a:ext cx="1653882" cy="2911674"/>
+              <a:ext cx="1653882" cy="1279645"/>
               <a:chOff x="9066910" y="2945375"/>
-              <a:chExt cx="1653881" cy="2911674"/>
+              <a:chExt cx="1653881" cy="1279645"/>
             </a:xfrm>
           </p:grpSpPr>
           <p:sp>
@@ -14381,7 +14352,7 @@
             <p:spPr>
               <a:xfrm>
                 <a:off x="9075902" y="2945375"/>
-                <a:ext cx="1644889" cy="2911674"/>
+                <a:ext cx="1644889" cy="1279645"/>
               </a:xfrm>
               <a:prstGeom prst="roundRect">
                 <a:avLst>
@@ -14562,72 +14533,6 @@
             </a:p>
           </p:txBody>
         </p:sp>
-        <p:pic>
-          <p:nvPicPr>
-            <p:cNvPr id="1425" name="Imagen 1424">
-              <a:extLst>
-                <a:ext uri="{FF2B5EF4-FFF2-40B4-BE49-F238E27FC236}">
-                  <a16:creationId xmlns:a16="http://schemas.microsoft.com/office/drawing/2014/main" id="{876AF0EA-D9F1-0AFC-0F5A-CFCBE0E5B8CE}"/>
-                </a:ext>
-              </a:extLst>
-            </p:cNvPr>
-            <p:cNvPicPr>
-              <a:picLocks noChangeAspect="1"/>
-            </p:cNvPicPr>
-            <p:nvPr/>
-          </p:nvPicPr>
-          <p:blipFill>
-            <a:blip r:embed="rId23">
-              <a:extLst>
-                <a:ext uri="{28A0092B-C50C-407E-A947-70E740481C1C}">
-                  <a14:useLocalDpi xmlns:a14="http://schemas.microsoft.com/office/drawing/2010/main" val="0"/>
-                </a:ext>
-              </a:extLst>
-            </a:blip>
-            <a:stretch>
-              <a:fillRect/>
-            </a:stretch>
-          </p:blipFill>
-          <p:spPr>
-            <a:xfrm>
-              <a:off x="5627644" y="4801900"/>
-              <a:ext cx="1344034" cy="958987"/>
-            </a:xfrm>
-            <a:prstGeom prst="rect">
-              <a:avLst/>
-            </a:prstGeom>
-          </p:spPr>
-        </p:pic>
-        <p:pic>
-          <p:nvPicPr>
-            <p:cNvPr id="1372" name="Imagen 1371" descr="machine learning - Difference between standardscaler and Normalizer in  sklearn.preprocessing - Stack Overflow">
-              <a:extLst>
-                <a:ext uri="{FF2B5EF4-FFF2-40B4-BE49-F238E27FC236}">
-                  <a16:creationId xmlns:a16="http://schemas.microsoft.com/office/drawing/2014/main" id="{3FD92362-3D86-846B-8814-5F37FC4DC894}"/>
-                </a:ext>
-              </a:extLst>
-            </p:cNvPr>
-            <p:cNvPicPr>
-              <a:picLocks noChangeAspect="1"/>
-            </p:cNvPicPr>
-            <p:nvPr/>
-          </p:nvPicPr>
-          <p:blipFill>
-            <a:blip r:embed="rId24"/>
-            <a:stretch>
-              <a:fillRect/>
-            </a:stretch>
-          </p:blipFill>
-          <p:spPr>
-            <a:xfrm>
-              <a:off x="5627644" y="5295422"/>
-              <a:ext cx="1344035" cy="1125320"/>
-            </a:xfrm>
-            <a:prstGeom prst="rect">
-              <a:avLst/>
-            </a:prstGeom>
-          </p:spPr>
-        </p:pic>
       </p:grpSp>
       <p:cxnSp>
         <p:nvCxnSpPr>
@@ -14646,9 +14551,9 @@
           <p:nvPr/>
         </p:nvCxnSpPr>
         <p:spPr>
-          <a:xfrm flipV="1">
-            <a:off x="5105966" y="5224851"/>
-            <a:ext cx="412390" cy="992"/>
+          <a:xfrm>
+            <a:off x="5105966" y="5225843"/>
+            <a:ext cx="412390" cy="1143"/>
           </a:xfrm>
           <a:prstGeom prst="bentConnector3">
             <a:avLst/>
@@ -14690,7 +14595,7 @@
           <a:blip>
             <a:extLst>
               <a:ext uri="{96DAC541-7B7A-43D3-8B79-37D633B846F1}">
-                <asvg:svgBlip xmlns:asvg="http://schemas.microsoft.com/office/drawing/2016/SVG/main" r:embed="rId25"/>
+                <asvg:svgBlip xmlns:asvg="http://schemas.microsoft.com/office/drawing/2016/SVG/main" r:embed="rId23"/>
               </a:ext>
             </a:extLst>
           </a:blip>
@@ -14700,7 +14605,7 @@
         </p:blipFill>
         <p:spPr>
           <a:xfrm>
-            <a:off x="5625497" y="3856014"/>
+            <a:off x="5625497" y="4674163"/>
             <a:ext cx="426461" cy="357117"/>
           </a:xfrm>
           <a:prstGeom prst="rect">
@@ -14948,7 +14853,7 @@
           <p:nvPr/>
         </p:nvPicPr>
         <p:blipFill>
-          <a:blip r:embed="rId26">
+          <a:blip r:embed="rId24">
             <a:extLst>
               <a:ext uri="{28A0092B-C50C-407E-A947-70E740481C1C}">
                 <a14:useLocalDpi xmlns:a14="http://schemas.microsoft.com/office/drawing/2010/main" val="0"/>
@@ -14961,7 +14866,7 @@
         </p:blipFill>
         <p:spPr>
           <a:xfrm>
-            <a:off x="9947574" y="4521988"/>
+            <a:off x="9910391" y="4885218"/>
             <a:ext cx="492510" cy="492510"/>
           </a:xfrm>
           <a:prstGeom prst="rect">
@@ -14987,7 +14892,7 @@
           <a:blip>
             <a:extLst>
               <a:ext uri="{96DAC541-7B7A-43D3-8B79-37D633B846F1}">
-                <asvg:svgBlip xmlns:asvg="http://schemas.microsoft.com/office/drawing/2016/SVG/main" r:embed="rId27"/>
+                <asvg:svgBlip xmlns:asvg="http://schemas.microsoft.com/office/drawing/2016/SVG/main" r:embed="rId25"/>
               </a:ext>
             </a:extLst>
           </a:blip>
@@ -15023,7 +14928,7 @@
           <a:blip>
             <a:extLst>
               <a:ext uri="{96DAC541-7B7A-43D3-8B79-37D633B846F1}">
-                <asvg:svgBlip xmlns:asvg="http://schemas.microsoft.com/office/drawing/2016/SVG/main" r:embed="rId27"/>
+                <asvg:svgBlip xmlns:asvg="http://schemas.microsoft.com/office/drawing/2016/SVG/main" r:embed="rId25"/>
               </a:ext>
             </a:extLst>
           </a:blip>
@@ -15033,7 +14938,7 @@
         </p:blipFill>
         <p:spPr>
           <a:xfrm>
-            <a:off x="10001178" y="3819141"/>
+            <a:off x="9963995" y="4182371"/>
             <a:ext cx="362195" cy="399663"/>
           </a:xfrm>
           <a:prstGeom prst="rect">
@@ -15055,7 +14960,7 @@
         </p:nvSpPr>
         <p:spPr>
           <a:xfrm>
-            <a:off x="10416881" y="3889692"/>
+            <a:off x="10379698" y="4252922"/>
             <a:ext cx="1310949" cy="262118"/>
           </a:xfrm>
           <a:prstGeom prst="rect">
@@ -15113,7 +15018,7 @@
         </p:blipFill>
         <p:spPr>
           <a:xfrm>
-            <a:off x="11745835" y="4347931"/>
+            <a:off x="11708652" y="4711161"/>
             <a:ext cx="292608" cy="292608"/>
           </a:xfrm>
           <a:prstGeom prst="rect">
@@ -15148,7 +15053,7 @@
         </p:blipFill>
         <p:spPr>
           <a:xfrm>
-            <a:off x="11745835" y="4544052"/>
+            <a:off x="11708652" y="4907282"/>
             <a:ext cx="292608" cy="292608"/>
           </a:xfrm>
           <a:prstGeom prst="rect">
@@ -15183,7 +15088,7 @@
         </p:blipFill>
         <p:spPr>
           <a:xfrm>
-            <a:off x="11786067" y="4787977"/>
+            <a:off x="11748884" y="5151207"/>
             <a:ext cx="231553" cy="231553"/>
           </a:xfrm>
           <a:prstGeom prst="rect">
@@ -15218,7 +15123,7 @@
         </p:blipFill>
         <p:spPr>
           <a:xfrm>
-            <a:off x="11752413" y="4963557"/>
+            <a:off x="11715230" y="5326787"/>
             <a:ext cx="292506" cy="292608"/>
           </a:xfrm>
           <a:prstGeom prst="rect">
@@ -15240,7 +15145,7 @@
         </p:nvSpPr>
         <p:spPr>
           <a:xfrm>
-            <a:off x="10468076" y="4416033"/>
+            <a:off x="10430893" y="4779263"/>
             <a:ext cx="1267329" cy="789201"/>
           </a:xfrm>
           <a:prstGeom prst="rect">
@@ -15310,14 +15215,14 @@
           <p:nvPr/>
         </p:nvPicPr>
         <p:blipFill>
-          <a:blip r:embed="rId28"/>
+          <a:blip r:embed="rId26"/>
           <a:stretch>
             <a:fillRect/>
           </a:stretch>
         </p:blipFill>
         <p:spPr>
           <a:xfrm>
-            <a:off x="9957643" y="5420011"/>
+            <a:off x="9920460" y="5783241"/>
             <a:ext cx="492510" cy="492510"/>
           </a:xfrm>
           <a:prstGeom prst="rect">
@@ -15339,7 +15244,7 @@
         </p:nvSpPr>
         <p:spPr>
           <a:xfrm>
-            <a:off x="10460501" y="5512140"/>
+            <a:off x="10423318" y="5875370"/>
             <a:ext cx="1267329" cy="338319"/>
           </a:xfrm>
           <a:prstGeom prst="rect">
@@ -15373,84 +15278,6 @@
           </a:p>
         </p:txBody>
       </p:sp>
-      <p:pic>
-        <p:nvPicPr>
-          <p:cNvPr id="1472" name="Imagen 1471">
-            <a:extLst>
-              <a:ext uri="{FF2B5EF4-FFF2-40B4-BE49-F238E27FC236}">
-                <a16:creationId xmlns:a16="http://schemas.microsoft.com/office/drawing/2014/main" id="{48D94A0E-CCA1-EBA4-A23C-0B58F936DF74}"/>
-              </a:ext>
-            </a:extLst>
-          </p:cNvPr>
-          <p:cNvPicPr>
-            <a:picLocks noChangeAspect="1"/>
-          </p:cNvPicPr>
-          <p:nvPr/>
-        </p:nvPicPr>
-        <p:blipFill>
-          <a:blip r:embed="rId29"/>
-          <a:stretch>
-            <a:fillRect/>
-          </a:stretch>
-        </p:blipFill>
-        <p:spPr>
-          <a:xfrm>
-            <a:off x="9957643" y="6128369"/>
-            <a:ext cx="492510" cy="492510"/>
-          </a:xfrm>
-          <a:prstGeom prst="rect">
-            <a:avLst/>
-          </a:prstGeom>
-        </p:spPr>
-      </p:pic>
-      <p:sp>
-        <p:nvSpPr>
-          <p:cNvPr id="1473" name="Text 34">
-            <a:extLst>
-              <a:ext uri="{FF2B5EF4-FFF2-40B4-BE49-F238E27FC236}">
-                <a16:creationId xmlns:a16="http://schemas.microsoft.com/office/drawing/2014/main" id="{AC77135D-EB02-6A0B-9B94-0F813D14D010}"/>
-              </a:ext>
-            </a:extLst>
-          </p:cNvPr>
-          <p:cNvSpPr/>
-          <p:nvPr/>
-        </p:nvSpPr>
-        <p:spPr>
-          <a:xfrm>
-            <a:off x="10468076" y="6205464"/>
-            <a:ext cx="1638025" cy="338319"/>
-          </a:xfrm>
-          <a:prstGeom prst="rect">
-            <a:avLst/>
-          </a:prstGeom>
-          <a:noFill/>
-          <a:ln/>
-        </p:spPr>
-        <p:txBody>
-          <a:bodyPr wrap="square" lIns="0" tIns="0" rIns="0" bIns="0" rtlCol="0" anchor="ctr"/>
-          <a:lstStyle/>
-          <a:p>
-            <a:pPr marL="0" indent="0">
-              <a:buNone/>
-            </a:pPr>
-            <a:r>
-              <a:rPr lang="en-US" sz="1600" b="1" dirty="0">
-                <a:solidFill>
-                  <a:srgbClr val="212121"/>
-                </a:solidFill>
-                <a:latin typeface="Courier New" panose="02070309020205020404" pitchFamily="49" charset="0"/>
-                <a:ea typeface="Calibri" pitchFamily="34" charset="-122"/>
-                <a:cs typeface="Courier New" panose="02070309020205020404" pitchFamily="49" charset="0"/>
-              </a:rPr>
-              <a:t>Probabilities</a:t>
-            </a:r>
-            <a:endParaRPr lang="en-US" sz="1600" dirty="0">
-              <a:latin typeface="Courier New" panose="02070309020205020404" pitchFamily="49" charset="0"/>
-              <a:cs typeface="Courier New" panose="02070309020205020404" pitchFamily="49" charset="0"/>
-            </a:endParaRPr>
-          </a:p>
-        </p:txBody>
-      </p:sp>
       <p:cxnSp>
         <p:nvCxnSpPr>
           <p:cNvPr id="1489" name="Conector: angular 1488">
@@ -15461,6 +15288,7 @@
             </a:extLst>
           </p:cNvPr>
           <p:cNvCxnSpPr>
+            <a:cxnSpLocks/>
             <a:stCxn id="1356" idx="3"/>
             <a:endCxn id="1452" idx="1"/>
           </p:cNvCxnSpPr>
@@ -15468,8 +15296,8 @@
         </p:nvCxnSpPr>
         <p:spPr>
           <a:xfrm flipV="1">
-            <a:off x="9227086" y="5225656"/>
-            <a:ext cx="686590" cy="902312"/>
+            <a:off x="9227086" y="5225843"/>
+            <a:ext cx="649407" cy="902125"/>
           </a:xfrm>
           <a:prstGeom prst="bentConnector3">
             <a:avLst>
@@ -15505,6 +15333,7 @@
             </a:extLst>
           </p:cNvPr>
           <p:cNvCxnSpPr>
+            <a:cxnSpLocks/>
             <a:stCxn id="1350" idx="3"/>
             <a:endCxn id="1452" idx="1"/>
           </p:cNvCxnSpPr>
@@ -15512,8 +15341,8 @@
         </p:nvCxnSpPr>
         <p:spPr>
           <a:xfrm flipV="1">
-            <a:off x="9223753" y="5225656"/>
-            <a:ext cx="689923" cy="1151"/>
+            <a:off x="9223753" y="5225843"/>
+            <a:ext cx="652740" cy="964"/>
           </a:xfrm>
           <a:prstGeom prst="bentConnector3">
             <a:avLst/>
@@ -15547,6 +15376,7 @@
             </a:extLst>
           </p:cNvPr>
           <p:cNvCxnSpPr>
+            <a:cxnSpLocks/>
             <a:stCxn id="1347" idx="3"/>
             <a:endCxn id="1452" idx="1"/>
           </p:cNvCxnSpPr>
@@ -15555,7 +15385,7 @@
         <p:spPr>
           <a:xfrm>
             <a:off x="9223753" y="4370770"/>
-            <a:ext cx="689923" cy="854886"/>
+            <a:ext cx="652740" cy="855073"/>
           </a:xfrm>
           <a:prstGeom prst="bentConnector3">
             <a:avLst/>
@@ -15589,6 +15419,7 @@
             </a:extLst>
           </p:cNvPr>
           <p:cNvCxnSpPr>
+            <a:cxnSpLocks/>
             <a:stCxn id="1440" idx="3"/>
             <a:endCxn id="1347" idx="1"/>
           </p:cNvCxnSpPr>
@@ -15597,7 +15428,7 @@
         <p:spPr>
           <a:xfrm flipV="1">
             <a:off x="7163246" y="4370770"/>
-            <a:ext cx="477039" cy="854081"/>
+            <a:ext cx="477039" cy="856216"/>
           </a:xfrm>
           <a:prstGeom prst="bentConnector3">
             <a:avLst/>
@@ -15631,15 +15462,16 @@
             </a:extLst>
           </p:cNvPr>
           <p:cNvCxnSpPr>
+            <a:cxnSpLocks/>
             <a:stCxn id="1440" idx="3"/>
             <a:endCxn id="1350" idx="1"/>
           </p:cNvCxnSpPr>
           <p:nvPr/>
         </p:nvCxnSpPr>
         <p:spPr>
-          <a:xfrm>
-            <a:off x="7163246" y="5224851"/>
-            <a:ext cx="477039" cy="1956"/>
+          <a:xfrm flipV="1">
+            <a:off x="7163246" y="5226807"/>
+            <a:ext cx="477039" cy="179"/>
           </a:xfrm>
           <a:prstGeom prst="bentConnector3">
             <a:avLst/>
@@ -15673,6 +15505,7 @@
             </a:extLst>
           </p:cNvPr>
           <p:cNvCxnSpPr>
+            <a:cxnSpLocks/>
             <a:stCxn id="1440" idx="3"/>
             <a:endCxn id="1356" idx="1"/>
           </p:cNvCxnSpPr>
@@ -15680,8 +15513,8 @@
         </p:nvCxnSpPr>
         <p:spPr>
           <a:xfrm>
-            <a:off x="7163246" y="5224851"/>
-            <a:ext cx="480372" cy="903117"/>
+            <a:off x="7163246" y="5226986"/>
+            <a:ext cx="480372" cy="900982"/>
           </a:xfrm>
           <a:prstGeom prst="bentConnector3">
             <a:avLst/>
@@ -15815,26 +15648,122 @@
           <a:p>
             <a:pPr algn="ctr"/>
             <a:r>
-              <a:rPr sz="1323" b="1">
+              <a:rPr sz="1323" b="1" dirty="0">
                 <a:solidFill>
                   <a:srgbClr val="000000"/>
                 </a:solidFill>
                 <a:latin typeface="Calibri"/>
               </a:rPr>
-              <a:t>POST   /api/lpmc/predict   |   /compare</a:t>
+              <a:t>POST   /</a:t>
+            </a:r>
+            <a:r>
+              <a:rPr sz="1323" b="1" dirty="0" err="1">
+                <a:solidFill>
+                  <a:srgbClr val="000000"/>
+                </a:solidFill>
+                <a:latin typeface="Calibri"/>
+              </a:rPr>
+              <a:t>api</a:t>
+            </a:r>
+            <a:r>
+              <a:rPr sz="1323" b="1" dirty="0">
+                <a:solidFill>
+                  <a:srgbClr val="000000"/>
+                </a:solidFill>
+                <a:latin typeface="Calibri"/>
+              </a:rPr>
+              <a:t>/</a:t>
+            </a:r>
+            <a:r>
+              <a:rPr sz="1323" b="1" dirty="0" err="1">
+                <a:solidFill>
+                  <a:srgbClr val="000000"/>
+                </a:solidFill>
+                <a:latin typeface="Calibri"/>
+              </a:rPr>
+              <a:t>lpmc</a:t>
+            </a:r>
+            <a:r>
+              <a:rPr sz="1323" b="1" dirty="0">
+                <a:solidFill>
+                  <a:srgbClr val="000000"/>
+                </a:solidFill>
+                <a:latin typeface="Calibri"/>
+              </a:rPr>
+              <a:t>/predict   |   /compare</a:t>
             </a:r>
           </a:p>
           <a:p>
             <a:pPr algn="ctr"/>
             <a:r>
-              <a:rPr sz="1005">
+              <a:rPr sz="1005" dirty="0" err="1">
                 <a:solidFill>
                   <a:srgbClr val="444444"/>
                 </a:solidFill>
                 <a:latin typeface="Calibri"/>
               </a:rPr>
-              <a:t>origen  ·  destino  ·  perfil sociodemográfico</a:t>
+              <a:t>origen</a:t>
             </a:r>
+            <a:r>
+              <a:rPr sz="1005" dirty="0">
+                <a:solidFill>
+                  <a:srgbClr val="444444"/>
+                </a:solidFill>
+                <a:latin typeface="Calibri"/>
+              </a:rPr>
+              <a:t>  ·  </a:t>
+            </a:r>
+            <a:r>
+              <a:rPr sz="1005" dirty="0" err="1">
+                <a:solidFill>
+                  <a:srgbClr val="444444"/>
+                </a:solidFill>
+                <a:latin typeface="Calibri"/>
+              </a:rPr>
+              <a:t>destino</a:t>
+            </a:r>
+            <a:r>
+              <a:rPr sz="1005" dirty="0">
+                <a:solidFill>
+                  <a:srgbClr val="444444"/>
+                </a:solidFill>
+                <a:latin typeface="Calibri"/>
+              </a:rPr>
+              <a:t>  ·  </a:t>
+            </a:r>
+            <a:r>
+              <a:rPr sz="1005" dirty="0" err="1">
+                <a:solidFill>
+                  <a:srgbClr val="444444"/>
+                </a:solidFill>
+                <a:latin typeface="Calibri"/>
+              </a:rPr>
+              <a:t>perfil</a:t>
+            </a:r>
+            <a:r>
+              <a:rPr sz="1005" dirty="0">
+                <a:solidFill>
+                  <a:srgbClr val="444444"/>
+                </a:solidFill>
+                <a:latin typeface="Calibri"/>
+              </a:rPr>
+              <a:t> </a:t>
+            </a:r>
+            <a:r>
+              <a:rPr sz="1005" dirty="0" err="1">
+                <a:solidFill>
+                  <a:srgbClr val="444444"/>
+                </a:solidFill>
+                <a:latin typeface="Calibri"/>
+              </a:rPr>
+              <a:t>sociodemográfico</a:t>
+            </a:r>
+            <a:endParaRPr sz="1005" dirty="0">
+              <a:solidFill>
+                <a:srgbClr val="444444"/>
+              </a:solidFill>
+              <a:latin typeface="Calibri"/>
+            </a:endParaRPr>
           </a:p>
         </p:txBody>
       </p:sp>
@@ -16697,7 +16626,7 @@
           <a:p>
             <a:pPr algn="ctr"/>
             <a:r>
-              <a:rPr sz="1323" b="1">
+              <a:rPr sz="1323" b="1" dirty="0" err="1">
                 <a:solidFill>
                   <a:srgbClr val="000000"/>
                 </a:solidFill>
@@ -16705,18 +16634,66 @@
               </a:rPr>
               <a:t>build_route_features</a:t>
             </a:r>
+            <a:endParaRPr sz="1323" b="1" dirty="0">
+              <a:solidFill>
+                <a:srgbClr val="000000"/>
+              </a:solidFill>
+              <a:latin typeface="Calibri"/>
+            </a:endParaRPr>
           </a:p>
           <a:p>
             <a:pPr algn="ctr"/>
             <a:r>
-              <a:rPr sz="1005">
+              <a:rPr sz="1005" dirty="0" err="1">
                 <a:solidFill>
                   <a:srgbClr val="444444"/>
                 </a:solidFill>
                 <a:latin typeface="Calibri"/>
               </a:rPr>
-              <a:t>duración (s) → horas  ·  legs OTP → dur_pt_*  ·  transbordos</a:t>
+              <a:t>duración</a:t>
             </a:r>
+            <a:r>
+              <a:rPr sz="1005" dirty="0">
+                <a:solidFill>
+                  <a:srgbClr val="444444"/>
+                </a:solidFill>
+                <a:latin typeface="Calibri"/>
+              </a:rPr>
+              <a:t> (s) → horas  ·  legs OTP → </a:t>
+            </a:r>
+            <a:r>
+              <a:rPr sz="1005" dirty="0" err="1">
+                <a:solidFill>
+                  <a:srgbClr val="444444"/>
+                </a:solidFill>
+                <a:latin typeface="Calibri"/>
+              </a:rPr>
+              <a:t>dur_pt</a:t>
+            </a:r>
+            <a:r>
+              <a:rPr sz="1005" dirty="0">
+                <a:solidFill>
+                  <a:srgbClr val="444444"/>
+                </a:solidFill>
+                <a:latin typeface="Calibri"/>
+              </a:rPr>
+              <a:t>_*  ·  </a:t>
+            </a:r>
+            <a:r>
+              <a:rPr sz="1005" dirty="0" err="1">
+                <a:solidFill>
+                  <a:srgbClr val="444444"/>
+                </a:solidFill>
+                <a:latin typeface="Calibri"/>
+              </a:rPr>
+              <a:t>transbordos</a:t>
+            </a:r>
+            <a:endParaRPr sz="1005" dirty="0">
+              <a:solidFill>
+                <a:srgbClr val="444444"/>
+              </a:solidFill>
+              <a:latin typeface="Calibri"/>
+            </a:endParaRPr>
           </a:p>
         </p:txBody>
       </p:sp>
@@ -16801,7 +16778,7 @@
           <a:p>
             <a:pPr algn="ctr"/>
             <a:r>
-              <a:rPr sz="1323" b="1">
+              <a:rPr sz="1323" b="1" dirty="0" err="1">
                 <a:solidFill>
                   <a:srgbClr val="000000"/>
                 </a:solidFill>
@@ -16809,18 +16786,57 @@
               </a:rPr>
               <a:t>build_feature_frame</a:t>
             </a:r>
+            <a:endParaRPr sz="1323" b="1" dirty="0">
+              <a:solidFill>
+                <a:srgbClr val="000000"/>
+              </a:solidFill>
+              <a:latin typeface="Calibri"/>
+            </a:endParaRPr>
           </a:p>
           <a:p>
             <a:pPr algn="ctr"/>
             <a:r>
-              <a:rPr sz="1005">
+              <a:rPr sz="1005" dirty="0">
                 <a:solidFill>
                   <a:srgbClr val="444444"/>
                 </a:solidFill>
                 <a:latin typeface="Calibri"/>
               </a:rPr>
-              <a:t>+ variables sociodemográficas  ·  one-hot purpose / fueltype</a:t>
+              <a:t>+ variables </a:t>
             </a:r>
+            <a:r>
+              <a:rPr sz="1005" dirty="0" err="1">
+                <a:solidFill>
+                  <a:srgbClr val="444444"/>
+                </a:solidFill>
+                <a:latin typeface="Calibri"/>
+              </a:rPr>
+              <a:t>sociodemográficas</a:t>
+            </a:r>
+            <a:r>
+              <a:rPr sz="1005" dirty="0">
+                <a:solidFill>
+                  <a:srgbClr val="444444"/>
+                </a:solidFill>
+                <a:latin typeface="Calibri"/>
+              </a:rPr>
+              <a:t>  ·  one-hot purpose / </a:t>
+            </a:r>
+            <a:r>
+              <a:rPr sz="1005" dirty="0" err="1">
+                <a:solidFill>
+                  <a:srgbClr val="444444"/>
+                </a:solidFill>
+                <a:latin typeface="Calibri"/>
+              </a:rPr>
+              <a:t>fueltype</a:t>
+            </a:r>
+            <a:endParaRPr sz="1005" dirty="0">
+              <a:solidFill>
+                <a:srgbClr val="444444"/>
+              </a:solidFill>
+              <a:latin typeface="Calibri"/>
+            </a:endParaRPr>
           </a:p>
         </p:txBody>
       </p:sp>
@@ -16905,7 +16921,7 @@
           <a:p>
             <a:pPr algn="ctr"/>
             <a:r>
-              <a:rPr sz="1323" b="1">
+              <a:rPr sz="1323" b="1" dirty="0" err="1">
                 <a:solidFill>
                   <a:srgbClr val="000000"/>
                 </a:solidFill>
@@ -16913,17 +16929,95 @@
               </a:rPr>
               <a:t>StandardScaler.transform</a:t>
             </a:r>
+            <a:endParaRPr sz="1323" b="1" dirty="0">
+              <a:solidFill>
+                <a:srgbClr val="000000"/>
+              </a:solidFill>
+              <a:latin typeface="Calibri"/>
+            </a:endParaRPr>
           </a:p>
           <a:p>
             <a:pPr algn="ctr"/>
             <a:r>
-              <a:rPr sz="1005">
+              <a:rPr sz="1005" dirty="0">
                 <a:solidFill>
                   <a:srgbClr val="444444"/>
                 </a:solidFill>
                 <a:latin typeface="Calibri"/>
               </a:rPr>
-              <a:t>columnas continuas  ·  μ y σ ajustados sobre el conjunto train</a:t>
+              <a:t>columnas </a:t>
+            </a:r>
+            <a:r>
+              <a:rPr sz="1005" dirty="0" err="1">
+                <a:solidFill>
+                  <a:srgbClr val="444444"/>
+                </a:solidFill>
+                <a:latin typeface="Calibri"/>
+              </a:rPr>
+              <a:t>continuas</a:t>
+            </a:r>
+            <a:r>
+              <a:rPr sz="1005" dirty="0">
+                <a:solidFill>
+                  <a:srgbClr val="444444"/>
+                </a:solidFill>
+                <a:latin typeface="Calibri"/>
+              </a:rPr>
+              <a:t>  ·  μ y σ </a:t>
+            </a:r>
+            <a:r>
+              <a:rPr sz="1005" dirty="0" err="1">
+                <a:solidFill>
+                  <a:srgbClr val="444444"/>
+                </a:solidFill>
+                <a:latin typeface="Calibri"/>
+              </a:rPr>
+              <a:t>ajustados</a:t>
+            </a:r>
+            <a:r>
+              <a:rPr sz="1005" dirty="0">
+                <a:solidFill>
+                  <a:srgbClr val="444444"/>
+                </a:solidFill>
+                <a:latin typeface="Calibri"/>
+              </a:rPr>
+              <a:t> </a:t>
+            </a:r>
+            <a:r>
+              <a:rPr sz="1005" dirty="0" err="1">
+                <a:solidFill>
+                  <a:srgbClr val="444444"/>
+                </a:solidFill>
+                <a:latin typeface="Calibri"/>
+              </a:rPr>
+              <a:t>sobre</a:t>
+            </a:r>
+            <a:r>
+              <a:rPr sz="1005" dirty="0">
+                <a:solidFill>
+                  <a:srgbClr val="444444"/>
+                </a:solidFill>
+                <a:latin typeface="Calibri"/>
+              </a:rPr>
+              <a:t> </a:t>
+            </a:r>
+            <a:r>
+              <a:rPr sz="1005" dirty="0" err="1">
+                <a:solidFill>
+                  <a:srgbClr val="444444"/>
+                </a:solidFill>
+                <a:latin typeface="Calibri"/>
+              </a:rPr>
+              <a:t>el</a:t>
+            </a:r>
+            <a:r>
+              <a:rPr sz="1005" dirty="0">
+                <a:solidFill>
+                  <a:srgbClr val="444444"/>
+                </a:solidFill>
+                <a:latin typeface="Calibri"/>
+              </a:rPr>
+              <a:t> conjunto train</a:t>
             </a:r>
           </a:p>
         </p:txBody>
@@ -18192,23 +18286,6 @@
 </file>
 
 <file path=customXml/item1.xml><?xml version="1.0" encoding="utf-8"?>
-<p:properties xmlns:p="http://schemas.microsoft.com/office/2006/metadata/properties" xmlns:xsi="http://www.w3.org/2001/XMLSchema-instance" xmlns:pc="http://schemas.microsoft.com/office/infopath/2007/PartnerControls">
-  <documentManagement>
-    <_activity xmlns="da169425-153d-4080-8705-45c92938e7f0" xsi:nil="true"/>
-  </documentManagement>
-</p:properties>
-</file>
-
-<file path=customXml/item2.xml><?xml version="1.0" encoding="utf-8"?>
-<?mso-contentType ?>
-<FormTemplates xmlns="http://schemas.microsoft.com/sharepoint/v3/contenttype/forms">
-  <Display>DocumentLibraryForm</Display>
-  <Edit>DocumentLibraryForm</Edit>
-  <New>DocumentLibraryForm</New>
-</FormTemplates>
-</file>
-
-<file path=customXml/item3.xml><?xml version="1.0" encoding="utf-8"?>
 <ct:contentTypeSchema xmlns:ct="http://schemas.microsoft.com/office/2006/metadata/contentType" xmlns:ma="http://schemas.microsoft.com/office/2006/metadata/properties/metaAttributes" ct:_="" ma:_="" ma:contentTypeName="Documento" ma:contentTypeID="0x010100DEA5B49C5DE5F44CB629258CFB70E19D" ma:contentTypeVersion="18" ma:contentTypeDescription="Crear nuevo documento." ma:contentTypeScope="" ma:versionID="74d7687ff137e87fb3b1bb4914d165da">
   <xsd:schema xmlns:xsd="http://www.w3.org/2001/XMLSchema" xmlns:xs="http://www.w3.org/2001/XMLSchema" xmlns:p="http://schemas.microsoft.com/office/2006/metadata/properties" xmlns:ns3="da169425-153d-4080-8705-45c92938e7f0" xmlns:ns4="89f1de4a-40f7-4e81-987b-401414521485" targetNamespace="http://schemas.microsoft.com/office/2006/metadata/properties" ma:root="true" ma:fieldsID="4c882593e756bab23045d9ebaf71ae2a" ns3:_="" ns4:_="">
     <xsd:import namespace="da169425-153d-4080-8705-45c92938e7f0"/>
@@ -18461,32 +18538,24 @@
 </ct:contentTypeSchema>
 </file>
 
-<file path=customXml/itemProps1.xml><?xml version="1.0" encoding="utf-8"?>
-<ds:datastoreItem xmlns:ds="http://schemas.openxmlformats.org/officeDocument/2006/customXml" ds:itemID="{E10D70F7-8416-46C5-896C-E4C67671FD25}">
-  <ds:schemaRefs>
-    <ds:schemaRef ds:uri="89f1de4a-40f7-4e81-987b-401414521485"/>
-    <ds:schemaRef ds:uri="http://purl.org/dc/dcmitype/"/>
-    <ds:schemaRef ds:uri="http://www.w3.org/XML/1998/namespace"/>
-    <ds:schemaRef ds:uri="http://purl.org/dc/terms/"/>
-    <ds:schemaRef ds:uri="http://schemas.microsoft.com/office/2006/metadata/properties"/>
-    <ds:schemaRef ds:uri="http://purl.org/dc/elements/1.1/"/>
-    <ds:schemaRef ds:uri="http://schemas.microsoft.com/office/2006/documentManagement/types"/>
-    <ds:schemaRef ds:uri="http://schemas.microsoft.com/office/infopath/2007/PartnerControls"/>
-    <ds:schemaRef ds:uri="http://schemas.openxmlformats.org/package/2006/metadata/core-properties"/>
-    <ds:schemaRef ds:uri="da169425-153d-4080-8705-45c92938e7f0"/>
-  </ds:schemaRefs>
-</ds:datastoreItem>
+<file path=customXml/item2.xml><?xml version="1.0" encoding="utf-8"?>
+<?mso-contentType ?>
+<FormTemplates xmlns="http://schemas.microsoft.com/sharepoint/v3/contenttype/forms">
+  <Display>DocumentLibraryForm</Display>
+  <Edit>DocumentLibraryForm</Edit>
+  <New>DocumentLibraryForm</New>
+</FormTemplates>
 </file>
 
-<file path=customXml/itemProps2.xml><?xml version="1.0" encoding="utf-8"?>
-<ds:datastoreItem xmlns:ds="http://schemas.openxmlformats.org/officeDocument/2006/customXml" ds:itemID="{4E1C400D-5C3C-43E3-9C88-F800C5BA2249}">
-  <ds:schemaRefs>
-    <ds:schemaRef ds:uri="http://schemas.microsoft.com/sharepoint/v3/contenttype/forms"/>
-  </ds:schemaRefs>
-</ds:datastoreItem>
+<file path=customXml/item3.xml><?xml version="1.0" encoding="utf-8"?>
+<p:properties xmlns:p="http://schemas.microsoft.com/office/2006/metadata/properties" xmlns:xsi="http://www.w3.org/2001/XMLSchema-instance" xmlns:pc="http://schemas.microsoft.com/office/infopath/2007/PartnerControls">
+  <documentManagement>
+    <_activity xmlns="da169425-153d-4080-8705-45c92938e7f0" xsi:nil="true"/>
+  </documentManagement>
+</p:properties>
 </file>
 
-<file path=customXml/itemProps3.xml><?xml version="1.0" encoding="utf-8"?>
+<file path=customXml/itemProps1.xml><?xml version="1.0" encoding="utf-8"?>
 <ds:datastoreItem xmlns:ds="http://schemas.openxmlformats.org/officeDocument/2006/customXml" ds:itemID="{F22018BE-1405-4A4B-BB67-C88962BABDE1}">
   <ds:schemaRefs>
     <ds:schemaRef ds:uri="http://schemas.microsoft.com/office/2006/metadata/contentType"/>
@@ -18503,4 +18572,29 @@
     <ds:schemaRef ds:uri="http://schemas.microsoft.com/internal/obd"/>
   </ds:schemaRefs>
 </ds:datastoreItem>
+</file>
+
+<file path=customXml/itemProps2.xml><?xml version="1.0" encoding="utf-8"?>
+<ds:datastoreItem xmlns:ds="http://schemas.openxmlformats.org/officeDocument/2006/customXml" ds:itemID="{4E1C400D-5C3C-43E3-9C88-F800C5BA2249}">
+  <ds:schemaRefs>
+    <ds:schemaRef ds:uri="http://schemas.microsoft.com/sharepoint/v3/contenttype/forms"/>
+  </ds:schemaRefs>
+</ds:datastoreItem>
+</file>
+
+<file path=customXml/itemProps3.xml><?xml version="1.0" encoding="utf-8"?>
+<ds:datastoreItem xmlns:ds="http://schemas.openxmlformats.org/officeDocument/2006/customXml" ds:itemID="{E10D70F7-8416-46C5-896C-E4C67671FD25}">
+  <ds:schemaRefs>
+    <ds:schemaRef ds:uri="89f1de4a-40f7-4e81-987b-401414521485"/>
+    <ds:schemaRef ds:uri="http://purl.org/dc/dcmitype/"/>
+    <ds:schemaRef ds:uri="http://www.w3.org/XML/1998/namespace"/>
+    <ds:schemaRef ds:uri="http://purl.org/dc/terms/"/>
+    <ds:schemaRef ds:uri="http://schemas.microsoft.com/office/2006/metadata/properties"/>
+    <ds:schemaRef ds:uri="http://purl.org/dc/elements/1.1/"/>
+    <ds:schemaRef ds:uri="http://schemas.microsoft.com/office/2006/documentManagement/types"/>
+    <ds:schemaRef ds:uri="http://schemas.microsoft.com/office/infopath/2007/PartnerControls"/>
+    <ds:schemaRef ds:uri="http://schemas.openxmlformats.org/package/2006/metadata/core-properties"/>
+    <ds:schemaRef ds:uri="da169425-153d-4080-8705-45c92938e7f0"/>
+  </ds:schemaRefs>
+</ds:datastoreItem>
 </file>
</xml_diff>